<commit_message>
feat: polish portal and add manual test kit
</commit_message>
<xml_diff>
--- a/docs/PromptShield_Pitch_Deck.pptx
+++ b/docs/PromptShield_Pitch_Deck.pptx
@@ -5,20 +5,20 @@
     <p:sldMasterId id="2147483648" r:id="rId1"/>
   </p:sldMasterIdLst>
   <p:sldIdLst>
-    <p:sldId id="256" r:id="rId7"/>
-    <p:sldId id="257" r:id="rId8"/>
-    <p:sldId id="258" r:id="rId9"/>
-    <p:sldId id="259" r:id="rId10"/>
-    <p:sldId id="260" r:id="rId11"/>
-    <p:sldId id="261" r:id="rId12"/>
-    <p:sldId id="262" r:id="rId13"/>
-    <p:sldId id="263" r:id="rId14"/>
-    <p:sldId id="264" r:id="rId15"/>
-    <p:sldId id="265" r:id="rId16"/>
-    <p:sldId id="266" r:id="rId17"/>
-    <p:sldId id="267" r:id="rId18"/>
+    <p:sldId id="256" r:id="rId2"/>
+    <p:sldId id="257" r:id="rId3"/>
+    <p:sldId id="258" r:id="rId4"/>
+    <p:sldId id="259" r:id="rId5"/>
+    <p:sldId id="260" r:id="rId6"/>
+    <p:sldId id="261" r:id="rId7"/>
+    <p:sldId id="262" r:id="rId8"/>
+    <p:sldId id="263" r:id="rId9"/>
+    <p:sldId id="264" r:id="rId10"/>
+    <p:sldId id="265" r:id="rId11"/>
+    <p:sldId id="266" r:id="rId12"/>
+    <p:sldId id="267" r:id="rId13"/>
   </p:sldIdLst>
-  <p:sldSz cx="12191695" cy="6858000" type="screen4x3"/>
+  <p:sldSz cx="12192000" cy="6858000"/>
   <p:notesSz cx="6858000" cy="9144000"/>
   <p:defaultTextStyle>
     <a:defPPr>
@@ -115,7 +115,60 @@
       </a:defRPr>
     </a:lvl9pPr>
   </p:defaultTextStyle>
+  <p:extLst>
+    <p:ext uri="{EFAFB233-063F-42B5-8137-9DF3F51BA10A}">
+      <p15:sldGuideLst xmlns:p15="http://schemas.microsoft.com/office/powerpoint/2012/main">
+        <p15:guide id="1" orient="horz" pos="2160">
+          <p15:clr>
+            <a:srgbClr val="A4A3A4"/>
+          </p15:clr>
+        </p15:guide>
+        <p15:guide id="2" pos="2880">
+          <p15:clr>
+            <a:srgbClr val="A4A3A4"/>
+          </p15:clr>
+        </p15:guide>
+      </p15:sldGuideLst>
+    </p:ext>
+  </p:extLst>
 </p:presentation>
+</file>
+
+<file path=ppt/changesInfos/changesInfo1.xml><?xml version="1.0" encoding="utf-8"?>
+<pc:chgInfo xmlns:a="http://schemas.openxmlformats.org/drawingml/2006/main" xmlns:r="http://schemas.openxmlformats.org/officeDocument/2006/relationships" xmlns:ac="http://schemas.microsoft.com/office/drawing/2013/main/command" xmlns:pc="http://schemas.microsoft.com/office/powerpoint/2013/main/command">
+  <pc:docChgLst>
+    <pc:chgData name="Ghosh, Subhamay (Cognizant)" userId="f7a00d04-e207-4175-8d22-50a3c0ab46ab" providerId="ADAL" clId="{C1737E7F-2612-4CF3-89B9-5AFAA483318F}"/>
+    <pc:docChg chg="modSld">
+      <pc:chgData name="Ghosh, Subhamay (Cognizant)" userId="f7a00d04-e207-4175-8d22-50a3c0ab46ab" providerId="ADAL" clId="{C1737E7F-2612-4CF3-89B9-5AFAA483318F}" dt="2026-09-29T08:58:14.446" v="2" actId="1076"/>
+      <pc:docMkLst>
+        <pc:docMk/>
+      </pc:docMkLst>
+      <pc:sldChg chg="modSp mod">
+        <pc:chgData name="Ghosh, Subhamay (Cognizant)" userId="f7a00d04-e207-4175-8d22-50a3c0ab46ab" providerId="ADAL" clId="{C1737E7F-2612-4CF3-89B9-5AFAA483318F}" dt="2026-09-29T08:58:14.446" v="2" actId="1076"/>
+        <pc:sldMkLst>
+          <pc:docMk/>
+          <pc:sldMk cId="0" sldId="265"/>
+        </pc:sldMkLst>
+        <pc:spChg chg="mod">
+          <ac:chgData name="Ghosh, Subhamay (Cognizant)" userId="f7a00d04-e207-4175-8d22-50a3c0ab46ab" providerId="ADAL" clId="{C1737E7F-2612-4CF3-89B9-5AFAA483318F}" dt="2026-09-29T08:58:14.446" v="2" actId="1076"/>
+          <ac:spMkLst>
+            <pc:docMk/>
+            <pc:sldMk cId="0" sldId="265"/>
+            <ac:spMk id="10" creationId="{00000000-0000-0000-0000-000000000000}"/>
+          </ac:spMkLst>
+        </pc:spChg>
+        <pc:spChg chg="mod">
+          <ac:chgData name="Ghosh, Subhamay (Cognizant)" userId="f7a00d04-e207-4175-8d22-50a3c0ab46ab" providerId="ADAL" clId="{C1737E7F-2612-4CF3-89B9-5AFAA483318F}" dt="2026-09-29T08:58:10.742" v="1" actId="1076"/>
+          <ac:spMkLst>
+            <pc:docMk/>
+            <pc:sldMk cId="0" sldId="265"/>
+            <ac:spMk id="11" creationId="{00000000-0000-0000-0000-000000000000}"/>
+          </ac:spMkLst>
+        </pc:spChg>
+      </pc:sldChg>
+    </pc:docChg>
+  </pc:docChgLst>
+</pc:chgInfo>
 </file>
 
 <file path=ppt/slideLayouts/slideLayout1.xml><?xml version="1.0" encoding="utf-8"?>
@@ -156,10 +209,9 @@
           <a:lstStyle/>
           <a:p>
             <a:r>
-              <a:rPr lang="en-US" smtClean="0"/>
+              <a:rPr lang="en-US"/>
               <a:t>Click to edit Master title style</a:t>
             </a:r>
-            <a:endParaRPr lang="en-US"/>
           </a:p>
         </p:txBody>
       </p:sp>
@@ -275,10 +327,9 @@
           </a:lstStyle>
           <a:p>
             <a:r>
-              <a:rPr lang="en-US" smtClean="0"/>
+              <a:rPr lang="en-US"/>
               <a:t>Click to edit Master subtitle style</a:t>
             </a:r>
-            <a:endParaRPr lang="en-US"/>
           </a:p>
         </p:txBody>
       </p:sp>
@@ -299,7 +350,7 @@
           <a:p>
             <a:fld id="{5BCAD085-E8A6-8845-BD4E-CB4CCA059FC4}" type="datetimeFigureOut">
               <a:rPr lang="en-US" smtClean="0"/>
-              <a:t>1/27/13</a:t>
+              <a:t>9/29/2026</a:t>
             </a:fld>
             <a:endParaRPr lang="en-US"/>
           </a:p>
@@ -393,10 +444,9 @@
           <a:lstStyle/>
           <a:p>
             <a:r>
-              <a:rPr lang="en-US" smtClean="0"/>
+              <a:rPr lang="en-US"/>
               <a:t>Click to edit Master title style</a:t>
             </a:r>
-            <a:endParaRPr lang="en-US"/>
           </a:p>
         </p:txBody>
       </p:sp>
@@ -417,38 +467,37 @@
           <a:p>
             <a:pPr lvl="0"/>
             <a:r>
-              <a:rPr lang="en-US" smtClean="0"/>
+              <a:rPr lang="en-US"/>
               <a:t>Click to edit Master text styles</a:t>
             </a:r>
           </a:p>
           <a:p>
             <a:pPr lvl="1"/>
             <a:r>
-              <a:rPr lang="en-US" smtClean="0"/>
+              <a:rPr lang="en-US"/>
               <a:t>Second level</a:t>
             </a:r>
           </a:p>
           <a:p>
             <a:pPr lvl="2"/>
             <a:r>
-              <a:rPr lang="en-US" smtClean="0"/>
+              <a:rPr lang="en-US"/>
               <a:t>Third level</a:t>
             </a:r>
           </a:p>
           <a:p>
             <a:pPr lvl="3"/>
             <a:r>
-              <a:rPr lang="en-US" smtClean="0"/>
+              <a:rPr lang="en-US"/>
               <a:t>Fourth level</a:t>
             </a:r>
           </a:p>
           <a:p>
             <a:pPr lvl="4"/>
             <a:r>
-              <a:rPr lang="en-US" smtClean="0"/>
+              <a:rPr lang="en-US"/>
               <a:t>Fifth level</a:t>
             </a:r>
-            <a:endParaRPr lang="en-US"/>
           </a:p>
         </p:txBody>
       </p:sp>
@@ -469,7 +518,7 @@
           <a:p>
             <a:fld id="{5BCAD085-E8A6-8845-BD4E-CB4CCA059FC4}" type="datetimeFigureOut">
               <a:rPr lang="en-US" smtClean="0"/>
-              <a:t>1/27/13</a:t>
+              <a:t>9/29/2026</a:t>
             </a:fld>
             <a:endParaRPr lang="en-US"/>
           </a:p>
@@ -568,10 +617,9 @@
           <a:lstStyle/>
           <a:p>
             <a:r>
-              <a:rPr lang="en-US" smtClean="0"/>
+              <a:rPr lang="en-US"/>
               <a:t>Click to edit Master title style</a:t>
             </a:r>
-            <a:endParaRPr lang="en-US"/>
           </a:p>
         </p:txBody>
       </p:sp>
@@ -597,38 +645,37 @@
           <a:p>
             <a:pPr lvl="0"/>
             <a:r>
-              <a:rPr lang="en-US" smtClean="0"/>
+              <a:rPr lang="en-US"/>
               <a:t>Click to edit Master text styles</a:t>
             </a:r>
           </a:p>
           <a:p>
             <a:pPr lvl="1"/>
             <a:r>
-              <a:rPr lang="en-US" smtClean="0"/>
+              <a:rPr lang="en-US"/>
               <a:t>Second level</a:t>
             </a:r>
           </a:p>
           <a:p>
             <a:pPr lvl="2"/>
             <a:r>
-              <a:rPr lang="en-US" smtClean="0"/>
+              <a:rPr lang="en-US"/>
               <a:t>Third level</a:t>
             </a:r>
           </a:p>
           <a:p>
             <a:pPr lvl="3"/>
             <a:r>
-              <a:rPr lang="en-US" smtClean="0"/>
+              <a:rPr lang="en-US"/>
               <a:t>Fourth level</a:t>
             </a:r>
           </a:p>
           <a:p>
             <a:pPr lvl="4"/>
             <a:r>
-              <a:rPr lang="en-US" smtClean="0"/>
+              <a:rPr lang="en-US"/>
               <a:t>Fifth level</a:t>
             </a:r>
-            <a:endParaRPr lang="en-US"/>
           </a:p>
         </p:txBody>
       </p:sp>
@@ -649,7 +696,7 @@
           <a:p>
             <a:fld id="{5BCAD085-E8A6-8845-BD4E-CB4CCA059FC4}" type="datetimeFigureOut">
               <a:rPr lang="en-US" smtClean="0"/>
-              <a:t>1/27/13</a:t>
+              <a:t>9/29/2026</a:t>
             </a:fld>
             <a:endParaRPr lang="en-US"/>
           </a:p>
@@ -743,10 +790,9 @@
           <a:lstStyle/>
           <a:p>
             <a:r>
-              <a:rPr lang="en-US" smtClean="0"/>
+              <a:rPr lang="en-US"/>
               <a:t>Click to edit Master title style</a:t>
             </a:r>
-            <a:endParaRPr lang="en-US"/>
           </a:p>
         </p:txBody>
       </p:sp>
@@ -767,38 +813,37 @@
           <a:p>
             <a:pPr lvl="0"/>
             <a:r>
-              <a:rPr lang="en-US" smtClean="0"/>
+              <a:rPr lang="en-US"/>
               <a:t>Click to edit Master text styles</a:t>
             </a:r>
           </a:p>
           <a:p>
             <a:pPr lvl="1"/>
             <a:r>
-              <a:rPr lang="en-US" smtClean="0"/>
+              <a:rPr lang="en-US"/>
               <a:t>Second level</a:t>
             </a:r>
           </a:p>
           <a:p>
             <a:pPr lvl="2"/>
             <a:r>
-              <a:rPr lang="en-US" smtClean="0"/>
+              <a:rPr lang="en-US"/>
               <a:t>Third level</a:t>
             </a:r>
           </a:p>
           <a:p>
             <a:pPr lvl="3"/>
             <a:r>
-              <a:rPr lang="en-US" smtClean="0"/>
+              <a:rPr lang="en-US"/>
               <a:t>Fourth level</a:t>
             </a:r>
           </a:p>
           <a:p>
             <a:pPr lvl="4"/>
             <a:r>
-              <a:rPr lang="en-US" smtClean="0"/>
+              <a:rPr lang="en-US"/>
               <a:t>Fifth level</a:t>
             </a:r>
-            <a:endParaRPr lang="en-US"/>
           </a:p>
         </p:txBody>
       </p:sp>
@@ -819,7 +864,7 @@
           <a:p>
             <a:fld id="{5BCAD085-E8A6-8845-BD4E-CB4CCA059FC4}" type="datetimeFigureOut">
               <a:rPr lang="en-US" smtClean="0"/>
-              <a:t>1/27/13</a:t>
+              <a:t>9/29/2026</a:t>
             </a:fld>
             <a:endParaRPr lang="en-US"/>
           </a:p>
@@ -922,10 +967,9 @@
           </a:lstStyle>
           <a:p>
             <a:r>
-              <a:rPr lang="en-US" smtClean="0"/>
+              <a:rPr lang="en-US"/>
               <a:t>Click to edit Master title style</a:t>
             </a:r>
-            <a:endParaRPr lang="en-US"/>
           </a:p>
         </p:txBody>
       </p:sp>
@@ -1042,7 +1086,7 @@
           <a:p>
             <a:pPr lvl="0"/>
             <a:r>
-              <a:rPr lang="en-US" smtClean="0"/>
+              <a:rPr lang="en-US"/>
               <a:t>Click to edit Master text styles</a:t>
             </a:r>
           </a:p>
@@ -1065,7 +1109,7 @@
           <a:p>
             <a:fld id="{5BCAD085-E8A6-8845-BD4E-CB4CCA059FC4}" type="datetimeFigureOut">
               <a:rPr lang="en-US" smtClean="0"/>
-              <a:t>1/27/13</a:t>
+              <a:t>9/29/2026</a:t>
             </a:fld>
             <a:endParaRPr lang="en-US"/>
           </a:p>
@@ -1159,10 +1203,9 @@
           <a:lstStyle/>
           <a:p>
             <a:r>
-              <a:rPr lang="en-US" smtClean="0"/>
+              <a:rPr lang="en-US"/>
               <a:t>Click to edit Master title style</a:t>
             </a:r>
-            <a:endParaRPr lang="en-US"/>
           </a:p>
         </p:txBody>
       </p:sp>
@@ -1216,38 +1259,37 @@
           <a:p>
             <a:pPr lvl="0"/>
             <a:r>
-              <a:rPr lang="en-US" smtClean="0"/>
+              <a:rPr lang="en-US"/>
               <a:t>Click to edit Master text styles</a:t>
             </a:r>
           </a:p>
           <a:p>
             <a:pPr lvl="1"/>
             <a:r>
-              <a:rPr lang="en-US" smtClean="0"/>
+              <a:rPr lang="en-US"/>
               <a:t>Second level</a:t>
             </a:r>
           </a:p>
           <a:p>
             <a:pPr lvl="2"/>
             <a:r>
-              <a:rPr lang="en-US" smtClean="0"/>
+              <a:rPr lang="en-US"/>
               <a:t>Third level</a:t>
             </a:r>
           </a:p>
           <a:p>
             <a:pPr lvl="3"/>
             <a:r>
-              <a:rPr lang="en-US" smtClean="0"/>
+              <a:rPr lang="en-US"/>
               <a:t>Fourth level</a:t>
             </a:r>
           </a:p>
           <a:p>
             <a:pPr lvl="4"/>
             <a:r>
-              <a:rPr lang="en-US" smtClean="0"/>
+              <a:rPr lang="en-US"/>
               <a:t>Fifth level</a:t>
             </a:r>
-            <a:endParaRPr lang="en-US"/>
           </a:p>
         </p:txBody>
       </p:sp>
@@ -1301,38 +1343,37 @@
           <a:p>
             <a:pPr lvl="0"/>
             <a:r>
-              <a:rPr lang="en-US" smtClean="0"/>
+              <a:rPr lang="en-US"/>
               <a:t>Click to edit Master text styles</a:t>
             </a:r>
           </a:p>
           <a:p>
             <a:pPr lvl="1"/>
             <a:r>
-              <a:rPr lang="en-US" smtClean="0"/>
+              <a:rPr lang="en-US"/>
               <a:t>Second level</a:t>
             </a:r>
           </a:p>
           <a:p>
             <a:pPr lvl="2"/>
             <a:r>
-              <a:rPr lang="en-US" smtClean="0"/>
+              <a:rPr lang="en-US"/>
               <a:t>Third level</a:t>
             </a:r>
           </a:p>
           <a:p>
             <a:pPr lvl="3"/>
             <a:r>
-              <a:rPr lang="en-US" smtClean="0"/>
+              <a:rPr lang="en-US"/>
               <a:t>Fourth level</a:t>
             </a:r>
           </a:p>
           <a:p>
             <a:pPr lvl="4"/>
             <a:r>
-              <a:rPr lang="en-US" smtClean="0"/>
+              <a:rPr lang="en-US"/>
               <a:t>Fifth level</a:t>
             </a:r>
-            <a:endParaRPr lang="en-US"/>
           </a:p>
         </p:txBody>
       </p:sp>
@@ -1353,7 +1394,7 @@
           <a:p>
             <a:fld id="{5BCAD085-E8A6-8845-BD4E-CB4CCA059FC4}" type="datetimeFigureOut">
               <a:rPr lang="en-US" smtClean="0"/>
-              <a:t>1/27/13</a:t>
+              <a:t>9/29/2026</a:t>
             </a:fld>
             <a:endParaRPr lang="en-US"/>
           </a:p>
@@ -1451,10 +1492,9 @@
           </a:lstStyle>
           <a:p>
             <a:r>
-              <a:rPr lang="en-US" smtClean="0"/>
+              <a:rPr lang="en-US"/>
               <a:t>Click to edit Master title style</a:t>
             </a:r>
-            <a:endParaRPr lang="en-US"/>
           </a:p>
         </p:txBody>
       </p:sp>
@@ -1517,7 +1557,7 @@
           <a:p>
             <a:pPr lvl="0"/>
             <a:r>
-              <a:rPr lang="en-US" smtClean="0"/>
+              <a:rPr lang="en-US"/>
               <a:t>Click to edit Master text styles</a:t>
             </a:r>
           </a:p>
@@ -1573,38 +1613,37 @@
           <a:p>
             <a:pPr lvl="0"/>
             <a:r>
-              <a:rPr lang="en-US" smtClean="0"/>
+              <a:rPr lang="en-US"/>
               <a:t>Click to edit Master text styles</a:t>
             </a:r>
           </a:p>
           <a:p>
             <a:pPr lvl="1"/>
             <a:r>
-              <a:rPr lang="en-US" smtClean="0"/>
+              <a:rPr lang="en-US"/>
               <a:t>Second level</a:t>
             </a:r>
           </a:p>
           <a:p>
             <a:pPr lvl="2"/>
             <a:r>
-              <a:rPr lang="en-US" smtClean="0"/>
+              <a:rPr lang="en-US"/>
               <a:t>Third level</a:t>
             </a:r>
           </a:p>
           <a:p>
             <a:pPr lvl="3"/>
             <a:r>
-              <a:rPr lang="en-US" smtClean="0"/>
+              <a:rPr lang="en-US"/>
               <a:t>Fourth level</a:t>
             </a:r>
           </a:p>
           <a:p>
             <a:pPr lvl="4"/>
             <a:r>
-              <a:rPr lang="en-US" smtClean="0"/>
+              <a:rPr lang="en-US"/>
               <a:t>Fifth level</a:t>
             </a:r>
-            <a:endParaRPr lang="en-US"/>
           </a:p>
         </p:txBody>
       </p:sp>
@@ -1667,7 +1706,7 @@
           <a:p>
             <a:pPr lvl="0"/>
             <a:r>
-              <a:rPr lang="en-US" smtClean="0"/>
+              <a:rPr lang="en-US"/>
               <a:t>Click to edit Master text styles</a:t>
             </a:r>
           </a:p>
@@ -1723,38 +1762,37 @@
           <a:p>
             <a:pPr lvl="0"/>
             <a:r>
-              <a:rPr lang="en-US" smtClean="0"/>
+              <a:rPr lang="en-US"/>
               <a:t>Click to edit Master text styles</a:t>
             </a:r>
           </a:p>
           <a:p>
             <a:pPr lvl="1"/>
             <a:r>
-              <a:rPr lang="en-US" smtClean="0"/>
+              <a:rPr lang="en-US"/>
               <a:t>Second level</a:t>
             </a:r>
           </a:p>
           <a:p>
             <a:pPr lvl="2"/>
             <a:r>
-              <a:rPr lang="en-US" smtClean="0"/>
+              <a:rPr lang="en-US"/>
               <a:t>Third level</a:t>
             </a:r>
           </a:p>
           <a:p>
             <a:pPr lvl="3"/>
             <a:r>
-              <a:rPr lang="en-US" smtClean="0"/>
+              <a:rPr lang="en-US"/>
               <a:t>Fourth level</a:t>
             </a:r>
           </a:p>
           <a:p>
             <a:pPr lvl="4"/>
             <a:r>
-              <a:rPr lang="en-US" smtClean="0"/>
+              <a:rPr lang="en-US"/>
               <a:t>Fifth level</a:t>
             </a:r>
-            <a:endParaRPr lang="en-US"/>
           </a:p>
         </p:txBody>
       </p:sp>
@@ -1775,7 +1813,7 @@
           <a:p>
             <a:fld id="{5BCAD085-E8A6-8845-BD4E-CB4CCA059FC4}" type="datetimeFigureOut">
               <a:rPr lang="en-US" smtClean="0"/>
-              <a:t>1/27/13</a:t>
+              <a:t>9/29/2026</a:t>
             </a:fld>
             <a:endParaRPr lang="en-US"/>
           </a:p>
@@ -1869,10 +1907,9 @@
           <a:lstStyle/>
           <a:p>
             <a:r>
-              <a:rPr lang="en-US" smtClean="0"/>
+              <a:rPr lang="en-US"/>
               <a:t>Click to edit Master title style</a:t>
             </a:r>
-            <a:endParaRPr lang="en-US"/>
           </a:p>
         </p:txBody>
       </p:sp>
@@ -1893,7 +1930,7 @@
           <a:p>
             <a:fld id="{5BCAD085-E8A6-8845-BD4E-CB4CCA059FC4}" type="datetimeFigureOut">
               <a:rPr lang="en-US" smtClean="0"/>
-              <a:t>1/27/13</a:t>
+              <a:t>9/29/2026</a:t>
             </a:fld>
             <a:endParaRPr lang="en-US"/>
           </a:p>
@@ -1988,7 +2025,7 @@
           <a:p>
             <a:fld id="{5BCAD085-E8A6-8845-BD4E-CB4CCA059FC4}" type="datetimeFigureOut">
               <a:rPr lang="en-US" smtClean="0"/>
-              <a:t>1/27/13</a:t>
+              <a:t>9/29/2026</a:t>
             </a:fld>
             <a:endParaRPr lang="en-US"/>
           </a:p>
@@ -2091,10 +2128,9 @@
           </a:lstStyle>
           <a:p>
             <a:r>
-              <a:rPr lang="en-US" smtClean="0"/>
+              <a:rPr lang="en-US"/>
               <a:t>Click to edit Master title style</a:t>
             </a:r>
-            <a:endParaRPr lang="en-US"/>
           </a:p>
         </p:txBody>
       </p:sp>
@@ -2148,38 +2184,37 @@
           <a:p>
             <a:pPr lvl="0"/>
             <a:r>
-              <a:rPr lang="en-US" smtClean="0"/>
+              <a:rPr lang="en-US"/>
               <a:t>Click to edit Master text styles</a:t>
             </a:r>
           </a:p>
           <a:p>
             <a:pPr lvl="1"/>
             <a:r>
-              <a:rPr lang="en-US" smtClean="0"/>
+              <a:rPr lang="en-US"/>
               <a:t>Second level</a:t>
             </a:r>
           </a:p>
           <a:p>
             <a:pPr lvl="2"/>
             <a:r>
-              <a:rPr lang="en-US" smtClean="0"/>
+              <a:rPr lang="en-US"/>
               <a:t>Third level</a:t>
             </a:r>
           </a:p>
           <a:p>
             <a:pPr lvl="3"/>
             <a:r>
-              <a:rPr lang="en-US" smtClean="0"/>
+              <a:rPr lang="en-US"/>
               <a:t>Fourth level</a:t>
             </a:r>
           </a:p>
           <a:p>
             <a:pPr lvl="4"/>
             <a:r>
-              <a:rPr lang="en-US" smtClean="0"/>
+              <a:rPr lang="en-US"/>
               <a:t>Fifth level</a:t>
             </a:r>
-            <a:endParaRPr lang="en-US"/>
           </a:p>
         </p:txBody>
       </p:sp>
@@ -2242,7 +2277,7 @@
           <a:p>
             <a:pPr lvl="0"/>
             <a:r>
-              <a:rPr lang="en-US" smtClean="0"/>
+              <a:rPr lang="en-US"/>
               <a:t>Click to edit Master text styles</a:t>
             </a:r>
           </a:p>
@@ -2265,7 +2300,7 @@
           <a:p>
             <a:fld id="{5BCAD085-E8A6-8845-BD4E-CB4CCA059FC4}" type="datetimeFigureOut">
               <a:rPr lang="en-US" smtClean="0"/>
-              <a:t>1/27/13</a:t>
+              <a:t>9/29/2026</a:t>
             </a:fld>
             <a:endParaRPr lang="en-US"/>
           </a:p>
@@ -2368,10 +2403,9 @@
           </a:lstStyle>
           <a:p>
             <a:r>
-              <a:rPr lang="en-US" smtClean="0"/>
+              <a:rPr lang="en-US"/>
               <a:t>Click to edit Master title style</a:t>
             </a:r>
-            <a:endParaRPr lang="en-US"/>
           </a:p>
         </p:txBody>
       </p:sp>
@@ -2495,7 +2529,7 @@
           <a:p>
             <a:pPr lvl="0"/>
             <a:r>
-              <a:rPr lang="en-US" smtClean="0"/>
+              <a:rPr lang="en-US"/>
               <a:t>Click to edit Master text styles</a:t>
             </a:r>
           </a:p>
@@ -2518,7 +2552,7 @@
           <a:p>
             <a:fld id="{5BCAD085-E8A6-8845-BD4E-CB4CCA059FC4}" type="datetimeFigureOut">
               <a:rPr lang="en-US" smtClean="0"/>
-              <a:t>1/27/13</a:t>
+              <a:t>9/29/2026</a:t>
             </a:fld>
             <a:endParaRPr lang="en-US"/>
           </a:p>
@@ -2627,10 +2661,9 @@
           <a:lstStyle/>
           <a:p>
             <a:r>
-              <a:rPr lang="en-US" smtClean="0"/>
+              <a:rPr lang="en-US"/>
               <a:t>Click to edit Master title style</a:t>
             </a:r>
-            <a:endParaRPr lang="en-US"/>
           </a:p>
         </p:txBody>
       </p:sp>
@@ -2661,38 +2694,37 @@
           <a:p>
             <a:pPr lvl="0"/>
             <a:r>
-              <a:rPr lang="en-US" smtClean="0"/>
+              <a:rPr lang="en-US"/>
               <a:t>Click to edit Master text styles</a:t>
             </a:r>
           </a:p>
           <a:p>
             <a:pPr lvl="1"/>
             <a:r>
-              <a:rPr lang="en-US" smtClean="0"/>
+              <a:rPr lang="en-US"/>
               <a:t>Second level</a:t>
             </a:r>
           </a:p>
           <a:p>
             <a:pPr lvl="2"/>
             <a:r>
-              <a:rPr lang="en-US" smtClean="0"/>
+              <a:rPr lang="en-US"/>
               <a:t>Third level</a:t>
             </a:r>
           </a:p>
           <a:p>
             <a:pPr lvl="3"/>
             <a:r>
-              <a:rPr lang="en-US" smtClean="0"/>
+              <a:rPr lang="en-US"/>
               <a:t>Fourth level</a:t>
             </a:r>
           </a:p>
           <a:p>
             <a:pPr lvl="4"/>
             <a:r>
-              <a:rPr lang="en-US" smtClean="0"/>
+              <a:rPr lang="en-US"/>
               <a:t>Fifth level</a:t>
             </a:r>
-            <a:endParaRPr lang="en-US"/>
           </a:p>
         </p:txBody>
       </p:sp>
@@ -2731,7 +2763,7 @@
           <a:p>
             <a:fld id="{5BCAD085-E8A6-8845-BD4E-CB4CCA059FC4}" type="datetimeFigureOut">
               <a:rPr lang="en-US" smtClean="0"/>
-              <a:t>1/27/13</a:t>
+              <a:t>9/29/2026</a:t>
             </a:fld>
             <a:endParaRPr lang="en-US"/>
           </a:p>
@@ -3090,7 +3122,7 @@
 </file>
 
 <file path=ppt/slides/slide1.xml><?xml version="1.0" encoding="utf-8"?>
-<p:sld xmlns:a="http://schemas.openxmlformats.org/drawingml/2006/main" xmlns:p="http://schemas.openxmlformats.org/presentationml/2006/main" xmlns:r="http://schemas.openxmlformats.org/officeDocument/2006/relationships">
+<p:sld xmlns:a="http://schemas.openxmlformats.org/drawingml/2006/main" xmlns:r="http://schemas.openxmlformats.org/officeDocument/2006/relationships" xmlns:p="http://schemas.openxmlformats.org/presentationml/2006/main">
   <p:cSld>
     <p:bg>
       <p:bgPr>
@@ -3106,7 +3138,14 @@
         <p:cNvGrpSpPr/>
         <p:nvPr/>
       </p:nvGrpSpPr>
-      <p:grpSpPr/>
+      <p:grpSpPr>
+        <a:xfrm>
+          <a:off x="0" y="0"/>
+          <a:ext cx="0" cy="0"/>
+          <a:chOff x="0" y="0"/>
+          <a:chExt cx="0" cy="0"/>
+        </a:xfrm>
+      </p:grpSpPr>
       <p:sp>
         <p:nvSpPr>
           <p:cNvPr id="2" name="TextBox 1"/>
@@ -3272,7 +3311,7 @@
 </file>
 
 <file path=ppt/slides/slide10.xml><?xml version="1.0" encoding="utf-8"?>
-<p:sld xmlns:a="http://schemas.openxmlformats.org/drawingml/2006/main" xmlns:p="http://schemas.openxmlformats.org/presentationml/2006/main" xmlns:r="http://schemas.openxmlformats.org/officeDocument/2006/relationships">
+<p:sld xmlns:a="http://schemas.openxmlformats.org/drawingml/2006/main" xmlns:r="http://schemas.openxmlformats.org/officeDocument/2006/relationships" xmlns:p="http://schemas.openxmlformats.org/presentationml/2006/main">
   <p:cSld>
     <p:bg>
       <p:bgPr>
@@ -3288,7 +3327,14 @@
         <p:cNvGrpSpPr/>
         <p:nvPr/>
       </p:nvGrpSpPr>
-      <p:grpSpPr/>
+      <p:grpSpPr>
+        <a:xfrm>
+          <a:off x="0" y="0"/>
+          <a:ext cx="0" cy="0"/>
+          <a:chOff x="0" y="0"/>
+          <a:chExt cx="0" cy="0"/>
+        </a:xfrm>
+      </p:grpSpPr>
       <p:sp>
         <p:nvSpPr>
           <p:cNvPr id="2" name="Rectangle 1"/>
@@ -3329,6 +3375,7 @@
           <a:lstStyle/>
           <a:p>
             <a:pPr algn="ctr"/>
+            <a:endParaRPr/>
           </a:p>
         </p:txBody>
       </p:sp>
@@ -3455,6 +3502,7 @@
           <a:lstStyle/>
           <a:p>
             <a:pPr algn="ctr"/>
+            <a:endParaRPr/>
           </a:p>
         </p:txBody>
       </p:sp>
@@ -3597,6 +3645,7 @@
           <a:lstStyle/>
           <a:p>
             <a:pPr algn="ctr"/>
+            <a:endParaRPr/>
           </a:p>
         </p:txBody>
       </p:sp>
@@ -3647,7 +3696,7 @@
         </p:nvSpPr>
         <p:spPr>
           <a:xfrm>
-            <a:off x="3429000" y="3291840"/>
+            <a:off x="3520440" y="3305556"/>
             <a:ext cx="2423160" cy="320040"/>
           </a:xfrm>
           <a:prstGeom prst="rect">
@@ -3667,7 +3716,7 @@
               </a:lnSpc>
             </a:pPr>
             <a:r>
-              <a:rPr sz="1150" b="0" i="0">
+              <a:rPr sz="1150" b="0" i="0" dirty="0">
                 <a:solidFill>
                   <a:srgbClr val="52514E"/>
                 </a:solidFill>
@@ -3683,7 +3732,7 @@
               </a:lnSpc>
             </a:pPr>
             <a:r>
-              <a:rPr sz="1150" b="0" i="0">
+              <a:rPr sz="1150" b="0" i="0" dirty="0">
                 <a:solidFill>
                   <a:srgbClr val="52514E"/>
                 </a:solidFill>
@@ -3702,7 +3751,7 @@
         </p:nvSpPr>
         <p:spPr>
           <a:xfrm>
-            <a:off x="3429000" y="3547872"/>
+            <a:off x="3429000" y="3758184"/>
             <a:ext cx="2423160" cy="274320"/>
           </a:xfrm>
           <a:prstGeom prst="rect">
@@ -3722,7 +3771,7 @@
               </a:lnSpc>
             </a:pPr>
             <a:r>
-              <a:rPr sz="900" b="0" i="1">
+              <a:rPr sz="900" b="0" i="1" dirty="0">
                 <a:solidFill>
                   <a:srgbClr val="898781"/>
                 </a:solidFill>
@@ -3738,7 +3787,7 @@
               </a:lnSpc>
             </a:pPr>
             <a:r>
-              <a:rPr sz="900" b="0" i="1">
+              <a:rPr sz="900" b="0" i="1" dirty="0">
                 <a:solidFill>
                   <a:srgbClr val="898781"/>
                 </a:solidFill>
@@ -3794,6 +3843,7 @@
           <a:lstStyle/>
           <a:p>
             <a:pPr algn="ctr"/>
+            <a:endParaRPr/>
           </a:p>
         </p:txBody>
       </p:sp>
@@ -3936,6 +3986,7 @@
           <a:lstStyle/>
           <a:p>
             <a:pPr algn="ctr"/>
+            <a:endParaRPr/>
           </a:p>
         </p:txBody>
       </p:sp>
@@ -4221,7 +4272,7 @@
 </file>
 
 <file path=ppt/slides/slide11.xml><?xml version="1.0" encoding="utf-8"?>
-<p:sld xmlns:a="http://schemas.openxmlformats.org/drawingml/2006/main" xmlns:p="http://schemas.openxmlformats.org/presentationml/2006/main" xmlns:r="http://schemas.openxmlformats.org/officeDocument/2006/relationships">
+<p:sld xmlns:a="http://schemas.openxmlformats.org/drawingml/2006/main" xmlns:r="http://schemas.openxmlformats.org/officeDocument/2006/relationships" xmlns:p="http://schemas.openxmlformats.org/presentationml/2006/main">
   <p:cSld>
     <p:bg>
       <p:bgPr>
@@ -4237,7 +4288,14 @@
         <p:cNvGrpSpPr/>
         <p:nvPr/>
       </p:nvGrpSpPr>
-      <p:grpSpPr/>
+      <p:grpSpPr>
+        <a:xfrm>
+          <a:off x="0" y="0"/>
+          <a:ext cx="0" cy="0"/>
+          <a:chOff x="0" y="0"/>
+          <a:chExt cx="0" cy="0"/>
+        </a:xfrm>
+      </p:grpSpPr>
       <p:sp>
         <p:nvSpPr>
           <p:cNvPr id="2" name="Rectangle 1"/>
@@ -4278,6 +4336,7 @@
           <a:lstStyle/>
           <a:p>
             <a:pPr algn="ctr"/>
+            <a:endParaRPr/>
           </a:p>
         </p:txBody>
       </p:sp>
@@ -4404,6 +4463,7 @@
           <a:lstStyle/>
           <a:p>
             <a:pPr algn="ctr"/>
+            <a:endParaRPr/>
           </a:p>
         </p:txBody>
       </p:sp>
@@ -4491,6 +4551,7 @@
           <a:lstStyle/>
           <a:p>
             <a:pPr algn="ctr"/>
+            <a:endParaRPr/>
           </a:p>
         </p:txBody>
       </p:sp>
@@ -4578,6 +4639,7 @@
           <a:lstStyle/>
           <a:p>
             <a:pPr algn="ctr"/>
+            <a:endParaRPr/>
           </a:p>
         </p:txBody>
       </p:sp>
@@ -4665,6 +4727,7 @@
           <a:lstStyle/>
           <a:p>
             <a:pPr algn="ctr"/>
+            <a:endParaRPr/>
           </a:p>
         </p:txBody>
       </p:sp>
@@ -4752,6 +4815,7 @@
           <a:lstStyle/>
           <a:p>
             <a:pPr algn="ctr"/>
+            <a:endParaRPr/>
           </a:p>
         </p:txBody>
       </p:sp>
@@ -4839,6 +4903,7 @@
           <a:lstStyle/>
           <a:p>
             <a:pPr algn="ctr"/>
+            <a:endParaRPr/>
           </a:p>
         </p:txBody>
       </p:sp>
@@ -4926,6 +4991,7 @@
           <a:lstStyle/>
           <a:p>
             <a:pPr algn="ctr"/>
+            <a:endParaRPr/>
           </a:p>
         </p:txBody>
       </p:sp>
@@ -5013,6 +5079,7 @@
           <a:lstStyle/>
           <a:p>
             <a:pPr algn="ctr"/>
+            <a:endParaRPr/>
           </a:p>
         </p:txBody>
       </p:sp>
@@ -5213,7 +5280,7 @@
 </file>
 
 <file path=ppt/slides/slide12.xml><?xml version="1.0" encoding="utf-8"?>
-<p:sld xmlns:a="http://schemas.openxmlformats.org/drawingml/2006/main" xmlns:p="http://schemas.openxmlformats.org/presentationml/2006/main" xmlns:r="http://schemas.openxmlformats.org/officeDocument/2006/relationships">
+<p:sld xmlns:a="http://schemas.openxmlformats.org/drawingml/2006/main" xmlns:r="http://schemas.openxmlformats.org/officeDocument/2006/relationships" xmlns:p="http://schemas.openxmlformats.org/presentationml/2006/main">
   <p:cSld>
     <p:bg>
       <p:bgPr>
@@ -5229,7 +5296,14 @@
         <p:cNvGrpSpPr/>
         <p:nvPr/>
       </p:nvGrpSpPr>
-      <p:grpSpPr/>
+      <p:grpSpPr>
+        <a:xfrm>
+          <a:off x="0" y="0"/>
+          <a:ext cx="0" cy="0"/>
+          <a:chOff x="0" y="0"/>
+          <a:chExt cx="0" cy="0"/>
+        </a:xfrm>
+      </p:grpSpPr>
       <p:sp>
         <p:nvSpPr>
           <p:cNvPr id="2" name="TextBox 1"/>
@@ -5395,7 +5469,7 @@
 </file>
 
 <file path=ppt/slides/slide2.xml><?xml version="1.0" encoding="utf-8"?>
-<p:sld xmlns:a="http://schemas.openxmlformats.org/drawingml/2006/main" xmlns:p="http://schemas.openxmlformats.org/presentationml/2006/main" xmlns:r="http://schemas.openxmlformats.org/officeDocument/2006/relationships">
+<p:sld xmlns:a="http://schemas.openxmlformats.org/drawingml/2006/main" xmlns:r="http://schemas.openxmlformats.org/officeDocument/2006/relationships" xmlns:p="http://schemas.openxmlformats.org/presentationml/2006/main">
   <p:cSld>
     <p:bg>
       <p:bgPr>
@@ -5411,7 +5485,14 @@
         <p:cNvGrpSpPr/>
         <p:nvPr/>
       </p:nvGrpSpPr>
-      <p:grpSpPr/>
+      <p:grpSpPr>
+        <a:xfrm>
+          <a:off x="0" y="0"/>
+          <a:ext cx="0" cy="0"/>
+          <a:chOff x="0" y="0"/>
+          <a:chExt cx="0" cy="0"/>
+        </a:xfrm>
+      </p:grpSpPr>
       <p:sp>
         <p:nvSpPr>
           <p:cNvPr id="2" name="Rectangle 1"/>
@@ -5452,6 +5533,7 @@
           <a:lstStyle/>
           <a:p>
             <a:pPr algn="ctr"/>
+            <a:endParaRPr/>
           </a:p>
         </p:txBody>
       </p:sp>
@@ -5705,6 +5787,7 @@
           <a:lstStyle/>
           <a:p>
             <a:pPr algn="ctr"/>
+            <a:endParaRPr/>
           </a:p>
         </p:txBody>
       </p:sp>
@@ -5790,6 +5873,12 @@
                 <a:spcPct val="100000"/>
               </a:lnSpc>
             </a:pPr>
+            <a:endParaRPr sz="1400" b="0" i="1">
+              <a:solidFill>
+                <a:srgbClr val="52514E"/>
+              </a:solidFill>
+              <a:latin typeface="Segoe UI"/>
+            </a:endParaRPr>
           </a:p>
           <a:p>
             <a:pPr algn="l">
@@ -5928,7 +6017,7 @@
 </file>
 
 <file path=ppt/slides/slide3.xml><?xml version="1.0" encoding="utf-8"?>
-<p:sld xmlns:a="http://schemas.openxmlformats.org/drawingml/2006/main" xmlns:p="http://schemas.openxmlformats.org/presentationml/2006/main" xmlns:r="http://schemas.openxmlformats.org/officeDocument/2006/relationships">
+<p:sld xmlns:a="http://schemas.openxmlformats.org/drawingml/2006/main" xmlns:r="http://schemas.openxmlformats.org/officeDocument/2006/relationships" xmlns:p="http://schemas.openxmlformats.org/presentationml/2006/main">
   <p:cSld>
     <p:bg>
       <p:bgPr>
@@ -5944,7 +6033,14 @@
         <p:cNvGrpSpPr/>
         <p:nvPr/>
       </p:nvGrpSpPr>
-      <p:grpSpPr/>
+      <p:grpSpPr>
+        <a:xfrm>
+          <a:off x="0" y="0"/>
+          <a:ext cx="0" cy="0"/>
+          <a:chOff x="0" y="0"/>
+          <a:chExt cx="0" cy="0"/>
+        </a:xfrm>
+      </p:grpSpPr>
       <p:sp>
         <p:nvSpPr>
           <p:cNvPr id="2" name="Rectangle 1"/>
@@ -5985,6 +6081,7 @@
           <a:lstStyle/>
           <a:p>
             <a:pPr algn="ctr"/>
+            <a:endParaRPr/>
           </a:p>
         </p:txBody>
       </p:sp>
@@ -6111,6 +6208,7 @@
           <a:lstStyle/>
           <a:p>
             <a:pPr algn="ctr"/>
+            <a:endParaRPr/>
           </a:p>
         </p:txBody>
       </p:sp>
@@ -6391,6 +6489,7 @@
           <a:lstStyle/>
           <a:p>
             <a:pPr algn="ctr"/>
+            <a:endParaRPr/>
           </a:p>
         </p:txBody>
       </p:sp>
@@ -6421,6 +6520,7 @@
                 <a:spcPct val="100000"/>
               </a:lnSpc>
             </a:pPr>
+            <a:endParaRPr/>
           </a:p>
         </p:txBody>
       </p:sp>
@@ -6469,6 +6569,7 @@
           <a:lstStyle/>
           <a:p>
             <a:pPr algn="ctr"/>
+            <a:endParaRPr/>
           </a:p>
         </p:txBody>
       </p:sp>
@@ -6499,6 +6600,7 @@
                 <a:spcPct val="100000"/>
               </a:lnSpc>
             </a:pPr>
+            <a:endParaRPr/>
           </a:p>
         </p:txBody>
       </p:sp>
@@ -6547,6 +6649,7 @@
           <a:lstStyle/>
           <a:p>
             <a:pPr algn="ctr"/>
+            <a:endParaRPr/>
           </a:p>
         </p:txBody>
       </p:sp>
@@ -6673,6 +6776,7 @@
           <a:lstStyle/>
           <a:p>
             <a:pPr algn="ctr"/>
+            <a:endParaRPr/>
           </a:p>
         </p:txBody>
       </p:sp>
@@ -6703,6 +6807,7 @@
                 <a:spcPct val="100000"/>
               </a:lnSpc>
             </a:pPr>
+            <a:endParaRPr/>
           </a:p>
         </p:txBody>
       </p:sp>
@@ -6751,6 +6856,7 @@
           <a:lstStyle/>
           <a:p>
             <a:pPr algn="ctr"/>
+            <a:endParaRPr/>
           </a:p>
         </p:txBody>
       </p:sp>
@@ -6781,6 +6887,7 @@
                 <a:spcPct val="100000"/>
               </a:lnSpc>
             </a:pPr>
+            <a:endParaRPr/>
           </a:p>
         </p:txBody>
       </p:sp>
@@ -6829,6 +6936,7 @@
           <a:lstStyle/>
           <a:p>
             <a:pPr algn="ctr"/>
+            <a:endParaRPr/>
           </a:p>
         </p:txBody>
       </p:sp>
@@ -6859,6 +6967,7 @@
                 <a:spcPct val="100000"/>
               </a:lnSpc>
             </a:pPr>
+            <a:endParaRPr/>
           </a:p>
         </p:txBody>
       </p:sp>
@@ -6946,6 +7055,7 @@
           <a:lstStyle/>
           <a:p>
             <a:pPr algn="ctr"/>
+            <a:endParaRPr/>
           </a:p>
         </p:txBody>
       </p:sp>
@@ -6976,6 +7086,7 @@
                 <a:spcPct val="100000"/>
               </a:lnSpc>
             </a:pPr>
+            <a:endParaRPr/>
           </a:p>
         </p:txBody>
       </p:sp>
@@ -7024,6 +7135,7 @@
           <a:lstStyle/>
           <a:p>
             <a:pPr algn="ctr"/>
+            <a:endParaRPr/>
           </a:p>
         </p:txBody>
       </p:sp>
@@ -7054,6 +7166,7 @@
                 <a:spcPct val="100000"/>
               </a:lnSpc>
             </a:pPr>
+            <a:endParaRPr/>
           </a:p>
         </p:txBody>
       </p:sp>
@@ -7102,6 +7215,7 @@
           <a:lstStyle/>
           <a:p>
             <a:pPr algn="ctr"/>
+            <a:endParaRPr/>
           </a:p>
         </p:txBody>
       </p:sp>
@@ -7132,6 +7246,7 @@
                 <a:spcPct val="100000"/>
               </a:lnSpc>
             </a:pPr>
+            <a:endParaRPr/>
           </a:p>
         </p:txBody>
       </p:sp>
@@ -7327,6 +7442,12 @@
                 <a:spcPct val="100000"/>
               </a:lnSpc>
             </a:pPr>
+            <a:endParaRPr sz="1400" b="0" i="0">
+              <a:solidFill>
+                <a:srgbClr val="52514E"/>
+              </a:solidFill>
+              <a:latin typeface="Segoe UI"/>
+            </a:endParaRPr>
           </a:p>
           <a:p>
             <a:pPr algn="l">
@@ -7465,7 +7586,7 @@
 </file>
 
 <file path=ppt/slides/slide4.xml><?xml version="1.0" encoding="utf-8"?>
-<p:sld xmlns:a="http://schemas.openxmlformats.org/drawingml/2006/main" xmlns:p="http://schemas.openxmlformats.org/presentationml/2006/main" xmlns:r="http://schemas.openxmlformats.org/officeDocument/2006/relationships">
+<p:sld xmlns:a="http://schemas.openxmlformats.org/drawingml/2006/main" xmlns:r="http://schemas.openxmlformats.org/officeDocument/2006/relationships" xmlns:p="http://schemas.openxmlformats.org/presentationml/2006/main">
   <p:cSld>
     <p:bg>
       <p:bgPr>
@@ -7481,7 +7602,14 @@
         <p:cNvGrpSpPr/>
         <p:nvPr/>
       </p:nvGrpSpPr>
-      <p:grpSpPr/>
+      <p:grpSpPr>
+        <a:xfrm>
+          <a:off x="0" y="0"/>
+          <a:ext cx="0" cy="0"/>
+          <a:chOff x="0" y="0"/>
+          <a:chExt cx="0" cy="0"/>
+        </a:xfrm>
+      </p:grpSpPr>
       <p:sp>
         <p:nvSpPr>
           <p:cNvPr id="2" name="Rectangle 1"/>
@@ -7522,6 +7650,7 @@
           <a:lstStyle/>
           <a:p>
             <a:pPr algn="ctr"/>
+            <a:endParaRPr/>
           </a:p>
         </p:txBody>
       </p:sp>
@@ -7714,7 +7843,7 @@
 </file>
 
 <file path=ppt/slides/slide5.xml><?xml version="1.0" encoding="utf-8"?>
-<p:sld xmlns:a="http://schemas.openxmlformats.org/drawingml/2006/main" xmlns:p="http://schemas.openxmlformats.org/presentationml/2006/main" xmlns:r="http://schemas.openxmlformats.org/officeDocument/2006/relationships">
+<p:sld xmlns:a="http://schemas.openxmlformats.org/drawingml/2006/main" xmlns:r="http://schemas.openxmlformats.org/officeDocument/2006/relationships" xmlns:p="http://schemas.openxmlformats.org/presentationml/2006/main">
   <p:cSld>
     <p:bg>
       <p:bgPr>
@@ -7730,7 +7859,14 @@
         <p:cNvGrpSpPr/>
         <p:nvPr/>
       </p:nvGrpSpPr>
-      <p:grpSpPr/>
+      <p:grpSpPr>
+        <a:xfrm>
+          <a:off x="0" y="0"/>
+          <a:ext cx="0" cy="0"/>
+          <a:chOff x="0" y="0"/>
+          <a:chExt cx="0" cy="0"/>
+        </a:xfrm>
+      </p:grpSpPr>
       <p:sp>
         <p:nvSpPr>
           <p:cNvPr id="2" name="Rectangle 1"/>
@@ -7771,6 +7907,7 @@
           <a:lstStyle/>
           <a:p>
             <a:pPr algn="ctr"/>
+            <a:endParaRPr/>
           </a:p>
         </p:txBody>
       </p:sp>
@@ -7897,6 +8034,7 @@
           <a:lstStyle/>
           <a:p>
             <a:pPr algn="ctr"/>
+            <a:endParaRPr/>
           </a:p>
         </p:txBody>
       </p:sp>
@@ -8073,6 +8211,7 @@
           <a:lstStyle/>
           <a:p>
             <a:pPr algn="ctr"/>
+            <a:endParaRPr/>
           </a:p>
         </p:txBody>
       </p:sp>
@@ -8291,7 +8430,7 @@
 </file>
 
 <file path=ppt/slides/slide6.xml><?xml version="1.0" encoding="utf-8"?>
-<p:sld xmlns:a="http://schemas.openxmlformats.org/drawingml/2006/main" xmlns:p="http://schemas.openxmlformats.org/presentationml/2006/main" xmlns:r="http://schemas.openxmlformats.org/officeDocument/2006/relationships">
+<p:sld xmlns:a="http://schemas.openxmlformats.org/drawingml/2006/main" xmlns:r="http://schemas.openxmlformats.org/officeDocument/2006/relationships" xmlns:p="http://schemas.openxmlformats.org/presentationml/2006/main">
   <p:cSld>
     <p:bg>
       <p:bgPr>
@@ -8307,7 +8446,14 @@
         <p:cNvGrpSpPr/>
         <p:nvPr/>
       </p:nvGrpSpPr>
-      <p:grpSpPr/>
+      <p:grpSpPr>
+        <a:xfrm>
+          <a:off x="0" y="0"/>
+          <a:ext cx="0" cy="0"/>
+          <a:chOff x="0" y="0"/>
+          <a:chExt cx="0" cy="0"/>
+        </a:xfrm>
+      </p:grpSpPr>
       <p:sp>
         <p:nvSpPr>
           <p:cNvPr id="2" name="Rectangle 1"/>
@@ -8348,6 +8494,7 @@
           <a:lstStyle/>
           <a:p>
             <a:pPr algn="ctr"/>
+            <a:endParaRPr/>
           </a:p>
         </p:txBody>
       </p:sp>
@@ -8474,6 +8621,7 @@
           <a:lstStyle/>
           <a:p>
             <a:pPr algn="ctr"/>
+            <a:endParaRPr/>
           </a:p>
         </p:txBody>
       </p:sp>
@@ -8635,6 +8783,7 @@
           <a:lstStyle/>
           <a:p>
             <a:pPr algn="ctr"/>
+            <a:endParaRPr/>
           </a:p>
         </p:txBody>
       </p:sp>
@@ -8838,7 +8987,7 @@
 </file>
 
 <file path=ppt/slides/slide7.xml><?xml version="1.0" encoding="utf-8"?>
-<p:sld xmlns:a="http://schemas.openxmlformats.org/drawingml/2006/main" xmlns:p="http://schemas.openxmlformats.org/presentationml/2006/main" xmlns:r="http://schemas.openxmlformats.org/officeDocument/2006/relationships">
+<p:sld xmlns:a="http://schemas.openxmlformats.org/drawingml/2006/main" xmlns:r="http://schemas.openxmlformats.org/officeDocument/2006/relationships" xmlns:p="http://schemas.openxmlformats.org/presentationml/2006/main">
   <p:cSld>
     <p:bg>
       <p:bgPr>
@@ -8854,7 +9003,14 @@
         <p:cNvGrpSpPr/>
         <p:nvPr/>
       </p:nvGrpSpPr>
-      <p:grpSpPr/>
+      <p:grpSpPr>
+        <a:xfrm>
+          <a:off x="0" y="0"/>
+          <a:ext cx="0" cy="0"/>
+          <a:chOff x="0" y="0"/>
+          <a:chExt cx="0" cy="0"/>
+        </a:xfrm>
+      </p:grpSpPr>
       <p:sp>
         <p:nvSpPr>
           <p:cNvPr id="2" name="Rectangle 1"/>
@@ -8895,6 +9051,7 @@
           <a:lstStyle/>
           <a:p>
             <a:pPr algn="ctr"/>
+            <a:endParaRPr/>
           </a:p>
         </p:txBody>
       </p:sp>
@@ -9076,6 +9233,7 @@
           <a:lstStyle/>
           <a:p>
             <a:pPr algn="ctr"/>
+            <a:endParaRPr/>
           </a:p>
         </p:txBody>
       </p:sp>
@@ -9193,6 +9351,12 @@
                 <a:spcPct val="100000"/>
               </a:lnSpc>
             </a:pPr>
+            <a:endParaRPr sz="1350" b="0" i="0">
+              <a:solidFill>
+                <a:srgbClr val="52514E"/>
+              </a:solidFill>
+              <a:latin typeface="Segoe UI"/>
+            </a:endParaRPr>
           </a:p>
           <a:p>
             <a:pPr algn="l">
@@ -9273,6 +9437,7 @@
           <a:lstStyle/>
           <a:p>
             <a:pPr algn="ctr"/>
+            <a:endParaRPr/>
           </a:p>
         </p:txBody>
       </p:sp>
@@ -9406,6 +9571,12 @@
                 <a:spcPct val="100000"/>
               </a:lnSpc>
             </a:pPr>
+            <a:endParaRPr sz="1350" b="0" i="0">
+              <a:solidFill>
+                <a:srgbClr val="52514E"/>
+              </a:solidFill>
+              <a:latin typeface="Segoe UI"/>
+            </a:endParaRPr>
           </a:p>
           <a:p>
             <a:pPr algn="l">
@@ -9544,7 +9715,7 @@
 </file>
 
 <file path=ppt/slides/slide8.xml><?xml version="1.0" encoding="utf-8"?>
-<p:sld xmlns:a="http://schemas.openxmlformats.org/drawingml/2006/main" xmlns:p="http://schemas.openxmlformats.org/presentationml/2006/main" xmlns:r="http://schemas.openxmlformats.org/officeDocument/2006/relationships">
+<p:sld xmlns:a="http://schemas.openxmlformats.org/drawingml/2006/main" xmlns:r="http://schemas.openxmlformats.org/officeDocument/2006/relationships" xmlns:p="http://schemas.openxmlformats.org/presentationml/2006/main">
   <p:cSld>
     <p:bg>
       <p:bgPr>
@@ -9560,7 +9731,14 @@
         <p:cNvGrpSpPr/>
         <p:nvPr/>
       </p:nvGrpSpPr>
-      <p:grpSpPr/>
+      <p:grpSpPr>
+        <a:xfrm>
+          <a:off x="0" y="0"/>
+          <a:ext cx="0" cy="0"/>
+          <a:chOff x="0" y="0"/>
+          <a:chExt cx="0" cy="0"/>
+        </a:xfrm>
+      </p:grpSpPr>
       <p:sp>
         <p:nvSpPr>
           <p:cNvPr id="2" name="Rectangle 1"/>
@@ -9601,6 +9779,7 @@
           <a:lstStyle/>
           <a:p>
             <a:pPr algn="ctr"/>
+            <a:endParaRPr/>
           </a:p>
         </p:txBody>
       </p:sp>
@@ -9727,6 +9906,7 @@
           <a:lstStyle/>
           <a:p>
             <a:pPr algn="ctr"/>
+            <a:endParaRPr/>
           </a:p>
         </p:txBody>
       </p:sp>
@@ -9767,7 +9947,7 @@
           </a:fontRef>
         </p:style>
         <p:txBody>
-          <a:bodyPr rtlCol="0" anchor="ctr" wrap="none"/>
+          <a:bodyPr wrap="none" rtlCol="0" anchor="ctr"/>
           <a:lstStyle/>
           <a:p>
             <a:pPr algn="ctr"/>
@@ -9866,6 +10046,7 @@
           <a:lstStyle/>
           <a:p>
             <a:pPr algn="ctr"/>
+            <a:endParaRPr/>
           </a:p>
         </p:txBody>
       </p:sp>
@@ -9906,7 +10087,7 @@
           </a:fontRef>
         </p:style>
         <p:txBody>
-          <a:bodyPr rtlCol="0" anchor="ctr" wrap="none"/>
+          <a:bodyPr wrap="none" rtlCol="0" anchor="ctr"/>
           <a:lstStyle/>
           <a:p>
             <a:pPr algn="ctr"/>
@@ -10005,6 +10186,7 @@
           <a:lstStyle/>
           <a:p>
             <a:pPr algn="ctr"/>
+            <a:endParaRPr/>
           </a:p>
         </p:txBody>
       </p:sp>
@@ -10045,7 +10227,7 @@
           </a:fontRef>
         </p:style>
         <p:txBody>
-          <a:bodyPr rtlCol="0" anchor="ctr" wrap="none"/>
+          <a:bodyPr wrap="none" rtlCol="0" anchor="ctr"/>
           <a:lstStyle/>
           <a:p>
             <a:pPr algn="ctr"/>
@@ -10144,6 +10326,7 @@
           <a:lstStyle/>
           <a:p>
             <a:pPr algn="ctr"/>
+            <a:endParaRPr/>
           </a:p>
         </p:txBody>
       </p:sp>
@@ -10184,7 +10367,7 @@
           </a:fontRef>
         </p:style>
         <p:txBody>
-          <a:bodyPr rtlCol="0" anchor="ctr" wrap="none"/>
+          <a:bodyPr wrap="none" rtlCol="0" anchor="ctr"/>
           <a:lstStyle/>
           <a:p>
             <a:pPr algn="ctr"/>
@@ -10283,6 +10466,7 @@
           <a:lstStyle/>
           <a:p>
             <a:pPr algn="ctr"/>
+            <a:endParaRPr/>
           </a:p>
         </p:txBody>
       </p:sp>
@@ -10323,7 +10507,7 @@
           </a:fontRef>
         </p:style>
         <p:txBody>
-          <a:bodyPr rtlCol="0" anchor="ctr" wrap="none"/>
+          <a:bodyPr wrap="none" rtlCol="0" anchor="ctr"/>
           <a:lstStyle/>
           <a:p>
             <a:pPr algn="ctr"/>
@@ -10422,6 +10606,7 @@
           <a:lstStyle/>
           <a:p>
             <a:pPr algn="ctr"/>
+            <a:endParaRPr/>
           </a:p>
         </p:txBody>
       </p:sp>
@@ -10462,7 +10647,7 @@
           </a:fontRef>
         </p:style>
         <p:txBody>
-          <a:bodyPr rtlCol="0" anchor="ctr" wrap="none"/>
+          <a:bodyPr wrap="none" rtlCol="0" anchor="ctr"/>
           <a:lstStyle/>
           <a:p>
             <a:pPr algn="ctr"/>
@@ -10561,6 +10746,7 @@
           <a:lstStyle/>
           <a:p>
             <a:pPr algn="ctr"/>
+            <a:endParaRPr/>
           </a:p>
         </p:txBody>
       </p:sp>
@@ -10601,7 +10787,7 @@
           </a:fontRef>
         </p:style>
         <p:txBody>
-          <a:bodyPr rtlCol="0" anchor="ctr" wrap="none"/>
+          <a:bodyPr wrap="none" rtlCol="0" anchor="ctr"/>
           <a:lstStyle/>
           <a:p>
             <a:pPr algn="ctr"/>
@@ -10700,6 +10886,7 @@
           <a:lstStyle/>
           <a:p>
             <a:pPr algn="ctr"/>
+            <a:endParaRPr/>
           </a:p>
         </p:txBody>
       </p:sp>
@@ -10740,7 +10927,7 @@
           </a:fontRef>
         </p:style>
         <p:txBody>
-          <a:bodyPr rtlCol="0" anchor="ctr" wrap="none"/>
+          <a:bodyPr wrap="none" rtlCol="0" anchor="ctr"/>
           <a:lstStyle/>
           <a:p>
             <a:pPr algn="ctr"/>
@@ -10839,6 +11026,7 @@
           <a:lstStyle/>
           <a:p>
             <a:pPr algn="ctr"/>
+            <a:endParaRPr/>
           </a:p>
         </p:txBody>
       </p:sp>
@@ -10879,7 +11067,7 @@
           </a:fontRef>
         </p:style>
         <p:txBody>
-          <a:bodyPr rtlCol="0" anchor="ctr" wrap="none"/>
+          <a:bodyPr wrap="none" rtlCol="0" anchor="ctr"/>
           <a:lstStyle/>
           <a:p>
             <a:pPr algn="ctr"/>
@@ -11059,7 +11247,7 @@
 </file>
 
 <file path=ppt/slides/slide9.xml><?xml version="1.0" encoding="utf-8"?>
-<p:sld xmlns:a="http://schemas.openxmlformats.org/drawingml/2006/main" xmlns:p="http://schemas.openxmlformats.org/presentationml/2006/main" xmlns:r="http://schemas.openxmlformats.org/officeDocument/2006/relationships">
+<p:sld xmlns:a="http://schemas.openxmlformats.org/drawingml/2006/main" xmlns:r="http://schemas.openxmlformats.org/officeDocument/2006/relationships" xmlns:p="http://schemas.openxmlformats.org/presentationml/2006/main">
   <p:cSld>
     <p:bg>
       <p:bgPr>
@@ -11075,7 +11263,14 @@
         <p:cNvGrpSpPr/>
         <p:nvPr/>
       </p:nvGrpSpPr>
-      <p:grpSpPr/>
+      <p:grpSpPr>
+        <a:xfrm>
+          <a:off x="0" y="0"/>
+          <a:ext cx="0" cy="0"/>
+          <a:chOff x="0" y="0"/>
+          <a:chExt cx="0" cy="0"/>
+        </a:xfrm>
+      </p:grpSpPr>
       <p:sp>
         <p:nvSpPr>
           <p:cNvPr id="2" name="Rectangle 1"/>
@@ -11116,6 +11311,7 @@
           <a:lstStyle/>
           <a:p>
             <a:pPr algn="ctr"/>
+            <a:endParaRPr/>
           </a:p>
         </p:txBody>
       </p:sp>
@@ -11242,6 +11438,7 @@
           <a:lstStyle/>
           <a:p>
             <a:pPr algn="ctr"/>
+            <a:endParaRPr/>
           </a:p>
         </p:txBody>
       </p:sp>

</xml_diff>